<commit_message>
Deck: fill slide 1 credits, align slide 2 columns, footnote copy
Slide 1 — Prepared by Affimarq, 25 August 2026.

Slide 2 — the left table and the right stack now open and close on the same
two lines (2.75 and 6.57in). The table is the flexible side: its row height
is derived from that span rather than typed loose, so the two columns stay
aligned if either side changes. Measured: 0.00pt at both top and bottom.

Slide 3 — the asterisk now says what the condition is: "Spent only when
affiliates are available for live selling."

Also set the canvas constant to the true 13.3333in. LAYOUT_WIDE is 13.333,
not 13.3, so every right-hand edge sat 0.033in inside its margin while the
left sat flush. Card and legend widths are now derived from the content
width instead of hardcoded. Margins measure 0.7000in on both sides.

Co-Authored-By: Claude Opus 5 <noreply@anthropic.com>
Claude-Session: https://claude.ai/code/session_01R5MfMhJkX2Cs5vpBAsW8HB
</commit_message>
<xml_diff>
--- a/toni-black/presentation/ToniBlack_Timeline_Budget.pptx
+++ b/toni-black/presentation/ToniBlack_Timeline_Budget.pptx
@@ -732,7 +732,7 @@
           <a:p>
             <a:r>
               <a:rPr lang="en-US" dirty="0"/>
-              <a:t>Ganti nama tim dan tanggal sebelum presentasi.</a:t>
+              <a:t>Slide pembuka. Isinya sudah lengkap, tidak ada yang perlu diganti.</a:t>
             </a:r>
             <a:endParaRPr lang="en-US" dirty="0"/>
           </a:p>
@@ -908,7 +908,7 @@
           <a:p>
             <a:r>
               <a:rPr lang="en-US" dirty="0"/>
-              <a:t>Total 24 juta sudah dicek: 7 + 7 + 10. Target revenue 48 juta adalah turunan dari ROAS 2 x budget 24 juta. Ganti keterangan tanda bintang sesuai kesepakatan. Grafik bisa diubah lewat klik kanan &gt; Edit Data.</a:t>
+              <a:t>Total 24 juta sudah dicek: 7 + 7 + 10. Target revenue 48 juta adalah turunan dari ROAS 2 x budget 24 juta. Pos Live Affiliate dipakai hanya kalau ada affiliate yang bisa diajak live selling. Grafik bisa diubah lewat klik kanan &gt; Edit Data.</a:t>
             </a:r>
             <a:endParaRPr lang="en-US" dirty="0"/>
           </a:p>
@@ -1609,7 +1609,7 @@
         </p:nvSpPr>
         <p:spPr>
           <a:xfrm>
-            <a:off x="6766560" y="5577840"/>
+            <a:off x="6797010" y="5577840"/>
             <a:ext cx="4754880" cy="365760"/>
           </a:xfrm>
           <a:prstGeom prst="rect">
@@ -1648,7 +1648,7 @@
                 <a:ea typeface="Arimo" pitchFamily="34" charset="-122"/>
                 <a:cs typeface="Arimo" pitchFamily="34" charset="-120"/>
               </a:rPr>
-              <a:t>Team name</a:t>
+              <a:t>Affimarq</a:t>
             </a:r>
             <a:pPr algn="r" indent="0" marL="0">
               <a:buNone/>
@@ -1676,7 +1676,7 @@
                 <a:ea typeface="Arimo" pitchFamily="34" charset="-122"/>
                 <a:cs typeface="Arimo" pitchFamily="34" charset="-120"/>
               </a:rPr>
-              <a:t>DD Month YYYY</a:t>
+              <a:t>25 August 2026</a:t>
             </a:r>
             <a:endParaRPr lang="en-US" sz="1150" dirty="0"/>
           </a:p>
@@ -1842,7 +1842,7 @@
                 <a:gridCol w="1965960"/>
                 <a:gridCol w="4892040"/>
               </a:tblGrid>
-              <a:tr h="548640">
+              <a:tr h="582168">
                 <a:tc>
                   <a:txBody>
                     <a:bodyPr/>
@@ -1980,7 +1980,7 @@
                   </a:tcPr>
                 </a:tc>
               </a:tr>
-              <a:tr h="548640">
+              <a:tr h="582168">
                 <a:tc>
                   <a:txBody>
                     <a:bodyPr/>
@@ -2118,7 +2118,7 @@
                   </a:tcPr>
                 </a:tc>
               </a:tr>
-              <a:tr h="548640">
+              <a:tr h="582168">
                 <a:tc>
                   <a:txBody>
                     <a:bodyPr/>
@@ -2256,7 +2256,7 @@
                   </a:tcPr>
                 </a:tc>
               </a:tr>
-              <a:tr h="548640">
+              <a:tr h="582168">
                 <a:tc>
                   <a:txBody>
                     <a:bodyPr/>
@@ -2394,7 +2394,7 @@
                   </a:tcPr>
                 </a:tc>
               </a:tr>
-              <a:tr h="548640">
+              <a:tr h="582168">
                 <a:tc>
                   <a:txBody>
                     <a:bodyPr/>
@@ -2532,7 +2532,7 @@
                   </a:tcPr>
                 </a:tc>
               </a:tr>
-              <a:tr h="548640">
+              <a:tr h="582168">
                 <a:tc>
                   <a:txBody>
                     <a:bodyPr/>
@@ -2683,7 +2683,7 @@
         <p:spPr>
           <a:xfrm>
             <a:off x="7955280" y="2514600"/>
-            <a:ext cx="3566160" cy="960120"/>
+            <a:ext cx="3596610" cy="960120"/>
           </a:xfrm>
           <a:prstGeom prst="roundRect">
             <a:avLst>
@@ -2710,7 +2710,7 @@
         <p:spPr>
           <a:xfrm>
             <a:off x="8211312" y="2660904"/>
-            <a:ext cx="3054096" cy="256032"/>
+            <a:ext cx="3084546" cy="256032"/>
           </a:xfrm>
           <a:prstGeom prst="rect">
             <a:avLst/>
@@ -2749,7 +2749,7 @@
         <p:spPr>
           <a:xfrm>
             <a:off x="8211312" y="2935224"/>
-            <a:ext cx="3054096" cy="393192"/>
+            <a:ext cx="3084546" cy="393192"/>
           </a:xfrm>
           <a:prstGeom prst="rect">
             <a:avLst/>
@@ -2788,7 +2788,7 @@
         <p:spPr>
           <a:xfrm>
             <a:off x="7955280" y="3730752"/>
-            <a:ext cx="3566160" cy="256032"/>
+            <a:ext cx="3596610" cy="256032"/>
           </a:xfrm>
           <a:prstGeom prst="rect">
             <a:avLst/>
@@ -2866,7 +2866,7 @@
         <p:spPr>
           <a:xfrm>
             <a:off x="8339328" y="4041648"/>
-            <a:ext cx="3182112" cy="292608"/>
+            <a:ext cx="3212562" cy="292608"/>
           </a:xfrm>
           <a:prstGeom prst="rect">
             <a:avLst/>
@@ -2944,7 +2944,7 @@
         <p:spPr>
           <a:xfrm>
             <a:off x="8339328" y="4370832"/>
-            <a:ext cx="3182112" cy="292608"/>
+            <a:ext cx="3212562" cy="292608"/>
           </a:xfrm>
           <a:prstGeom prst="rect">
             <a:avLst/>
@@ -3022,7 +3022,7 @@
         <p:spPr>
           <a:xfrm>
             <a:off x="8339328" y="4700016"/>
-            <a:ext cx="3182112" cy="292608"/>
+            <a:ext cx="3212562" cy="292608"/>
           </a:xfrm>
           <a:prstGeom prst="rect">
             <a:avLst/>
@@ -3061,7 +3061,7 @@
         <p:spPr>
           <a:xfrm>
             <a:off x="7955280" y="5138928"/>
-            <a:ext cx="3566160" cy="868680"/>
+            <a:ext cx="3596610" cy="868680"/>
           </a:xfrm>
           <a:prstGeom prst="roundRect">
             <a:avLst>
@@ -3088,7 +3088,7 @@
         <p:spPr>
           <a:xfrm>
             <a:off x="8211312" y="5285232"/>
-            <a:ext cx="3054096" cy="256032"/>
+            <a:ext cx="3084546" cy="256032"/>
           </a:xfrm>
           <a:prstGeom prst="rect">
             <a:avLst/>
@@ -3127,7 +3127,7 @@
         <p:spPr>
           <a:xfrm>
             <a:off x="8211312" y="5559552"/>
-            <a:ext cx="3054096" cy="301752"/>
+            <a:ext cx="3084546" cy="301752"/>
           </a:xfrm>
           <a:prstGeom prst="rect">
             <a:avLst/>
@@ -3300,7 +3300,7 @@
         <p:spPr>
           <a:xfrm>
             <a:off x="640080" y="2487168"/>
-            <a:ext cx="3502152" cy="960120"/>
+            <a:ext cx="3512302" cy="960120"/>
           </a:xfrm>
           <a:prstGeom prst="roundRect">
             <a:avLst>
@@ -3327,7 +3327,7 @@
         <p:spPr>
           <a:xfrm>
             <a:off x="896112" y="2633472"/>
-            <a:ext cx="2990088" cy="256032"/>
+            <a:ext cx="3000238" cy="256032"/>
           </a:xfrm>
           <a:prstGeom prst="rect">
             <a:avLst/>
@@ -3366,7 +3366,7 @@
         <p:spPr>
           <a:xfrm>
             <a:off x="896112" y="2907792"/>
-            <a:ext cx="2990088" cy="393192"/>
+            <a:ext cx="3000238" cy="393192"/>
           </a:xfrm>
           <a:prstGeom prst="rect">
             <a:avLst/>
@@ -3404,8 +3404,8 @@
         </p:nvSpPr>
         <p:spPr>
           <a:xfrm>
-            <a:off x="4329684" y="2487168"/>
-            <a:ext cx="3502152" cy="960120"/>
+            <a:off x="4339834" y="2487168"/>
+            <a:ext cx="3512302" cy="960120"/>
           </a:xfrm>
           <a:prstGeom prst="roundRect">
             <a:avLst>
@@ -3431,8 +3431,8 @@
         </p:nvSpPr>
         <p:spPr>
           <a:xfrm>
-            <a:off x="4585716" y="2633472"/>
-            <a:ext cx="2990088" cy="256032"/>
+            <a:off x="4595866" y="2633472"/>
+            <a:ext cx="3000238" cy="256032"/>
           </a:xfrm>
           <a:prstGeom prst="rect">
             <a:avLst/>
@@ -3470,8 +3470,8 @@
         </p:nvSpPr>
         <p:spPr>
           <a:xfrm>
-            <a:off x="4585716" y="2907792"/>
-            <a:ext cx="2990088" cy="393192"/>
+            <a:off x="4595866" y="2907792"/>
+            <a:ext cx="3000238" cy="393192"/>
           </a:xfrm>
           <a:prstGeom prst="rect">
             <a:avLst/>
@@ -3509,8 +3509,8 @@
         </p:nvSpPr>
         <p:spPr>
           <a:xfrm>
-            <a:off x="8019288" y="2487168"/>
-            <a:ext cx="3502152" cy="960120"/>
+            <a:off x="8039588" y="2487168"/>
+            <a:ext cx="3512302" cy="960120"/>
           </a:xfrm>
           <a:prstGeom prst="roundRect">
             <a:avLst>
@@ -3536,8 +3536,8 @@
         </p:nvSpPr>
         <p:spPr>
           <a:xfrm>
-            <a:off x="8275320" y="2633472"/>
-            <a:ext cx="2990088" cy="256032"/>
+            <a:off x="8295620" y="2633472"/>
+            <a:ext cx="3000238" cy="256032"/>
           </a:xfrm>
           <a:prstGeom prst="rect">
             <a:avLst/>
@@ -3575,8 +3575,8 @@
         </p:nvSpPr>
         <p:spPr>
           <a:xfrm>
-            <a:off x="8275320" y="2907792"/>
-            <a:ext cx="2990088" cy="393192"/>
+            <a:off x="8295620" y="2907792"/>
+            <a:ext cx="3000238" cy="393192"/>
           </a:xfrm>
           <a:prstGeom prst="rect">
             <a:avLst/>
@@ -4755,7 +4755,7 @@
         </p:nvSpPr>
         <p:spPr>
           <a:xfrm>
-            <a:off x="10744200" y="4041648"/>
+            <a:off x="10774650" y="4041648"/>
             <a:ext cx="777240" cy="292608"/>
           </a:xfrm>
           <a:prstGeom prst="rect">
@@ -4858,7 +4858,7 @@
         </p:nvSpPr>
         <p:spPr>
           <a:xfrm>
-            <a:off x="10744200" y="4425696"/>
+            <a:off x="10774650" y="4425696"/>
             <a:ext cx="777240" cy="292608"/>
           </a:xfrm>
           <a:prstGeom prst="rect">
@@ -4961,7 +4961,7 @@
         </p:nvSpPr>
         <p:spPr>
           <a:xfrm>
-            <a:off x="10744200" y="4809744"/>
+            <a:off x="10774650" y="4809744"/>
             <a:ext cx="777240" cy="292608"/>
           </a:xfrm>
           <a:prstGeom prst="rect">
@@ -5025,7 +5025,7 @@
                 <a:ea typeface="Arimo" pitchFamily="34" charset="-122"/>
                 <a:cs typeface="Arimo" pitchFamily="34" charset="-120"/>
               </a:rPr>
-              <a:t>*  Add the note for this line.</a:t>
+              <a:t>*  Spent only when affiliates are available for live selling.</a:t>
             </a:r>
             <a:endParaRPr lang="en-US" sz="1100" dirty="0"/>
           </a:p>

</xml_diff>